<commit_message>
feat(qualite): vérificateur de synchronisation inter-livrables + diapo validation externe
- scripts/check_sync_livrables.py : compare les chiffres clés (RF, AUC externe,
  base consolidée, nb tests) entre mémoire, README, PPT, notebook, guide et
  rapports JSON ; exit 1 au moindre écart
- PPT diapo 13 : carte AUC 0,753 (validation externe) ajoutée — le guide de
  soutenance citait un chiffre absent de l'écran
- mémoire : formulation honnête du test E2E sensible à l'ordre d'exécution

Co-Authored-By: Claude Fable 5 <noreply@anthropic.com>
</commit_message>
<xml_diff>
--- a/reports/soutenance/MBEUMI_Wilfried_SOUTENANCE.pptx
+++ b/reports/soutenance/MBEUMI_Wilfried_SOUTENANCE.pptx
@@ -4597,11 +4597,11 @@
         <p:spPr>
           <a:xfrm>
             <a:off x="822960" y="1920240"/>
-            <a:ext cx="3383280" cy="2377440"/>
+            <a:ext cx="3383280" cy="2103120"/>
           </a:xfrm>
           <a:prstGeom prst="roundRect">
             <a:avLst>
-              <a:gd name="adj" fmla="val 3077"/>
+              <a:gd name="adj" fmla="val 3478"/>
             </a:avLst>
           </a:prstGeom>
           <a:solidFill>
@@ -4623,7 +4623,7 @@
         </p:nvSpPr>
         <p:spPr>
           <a:xfrm>
-            <a:off x="822960" y="2331720"/>
+            <a:off x="822960" y="2286000"/>
             <a:ext cx="3383280" cy="868680"/>
           </a:xfrm>
           <a:prstGeom prst="rect">
@@ -4662,7 +4662,7 @@
         </p:nvSpPr>
         <p:spPr>
           <a:xfrm>
-            <a:off x="822960" y="3200400"/>
+            <a:off x="822960" y="3154680"/>
             <a:ext cx="3383280" cy="594360"/>
           </a:xfrm>
           <a:prstGeom prst="rect">
@@ -4719,11 +4719,11 @@
         <p:spPr>
           <a:xfrm>
             <a:off x="4407408" y="1920240"/>
-            <a:ext cx="3383280" cy="2377440"/>
+            <a:ext cx="3383280" cy="2103120"/>
           </a:xfrm>
           <a:prstGeom prst="roundRect">
             <a:avLst>
-              <a:gd name="adj" fmla="val 3077"/>
+              <a:gd name="adj" fmla="val 3478"/>
             </a:avLst>
           </a:prstGeom>
           <a:solidFill>
@@ -4745,7 +4745,7 @@
         </p:nvSpPr>
         <p:spPr>
           <a:xfrm>
-            <a:off x="4407408" y="2331720"/>
+            <a:off x="4407408" y="2286000"/>
             <a:ext cx="3383280" cy="868680"/>
           </a:xfrm>
           <a:prstGeom prst="rect">
@@ -4784,7 +4784,7 @@
         </p:nvSpPr>
         <p:spPr>
           <a:xfrm>
-            <a:off x="4407408" y="3200400"/>
+            <a:off x="4407408" y="3154680"/>
             <a:ext cx="3383280" cy="594360"/>
           </a:xfrm>
           <a:prstGeom prst="rect">
@@ -4841,11 +4841,11 @@
         <p:spPr>
           <a:xfrm>
             <a:off x="7991856" y="1920240"/>
-            <a:ext cx="3383280" cy="2377440"/>
+            <a:ext cx="3383280" cy="2103120"/>
           </a:xfrm>
           <a:prstGeom prst="roundRect">
             <a:avLst>
-              <a:gd name="adj" fmla="val 3077"/>
+              <a:gd name="adj" fmla="val 3478"/>
             </a:avLst>
           </a:prstGeom>
           <a:solidFill>
@@ -4867,7 +4867,7 @@
         </p:nvSpPr>
         <p:spPr>
           <a:xfrm>
-            <a:off x="7991856" y="2331720"/>
+            <a:off x="7991856" y="2286000"/>
             <a:ext cx="3383280" cy="868680"/>
           </a:xfrm>
           <a:prstGeom prst="rect">
@@ -4892,7 +4892,7 @@
                 <a:ea typeface="Cambria" pitchFamily="34" charset="-122"/>
                 <a:cs typeface="Cambria" pitchFamily="34" charset="-120"/>
               </a:rPr>
-              <a:t>2</a:t>
+              <a:t>0,753</a:t>
             </a:r>
             <a:endParaRPr lang="en-US" sz="4800" dirty="0"/>
           </a:p>
@@ -4906,7 +4906,7 @@
         </p:nvSpPr>
         <p:spPr>
           <a:xfrm>
-            <a:off x="7991856" y="3200400"/>
+            <a:off x="7991856" y="3154680"/>
             <a:ext cx="3383280" cy="594360"/>
           </a:xfrm>
           <a:prstGeom prst="rect">
@@ -4931,7 +4931,7 @@
                 <a:ea typeface="Calibri" pitchFamily="34" charset="-122"/>
                 <a:cs typeface="Calibri" pitchFamily="34" charset="-120"/>
               </a:rPr>
-              <a:t>langues (FR/EN), zéro fuite</a:t>
+              <a:t>AUC en validation externe sur</a:t>
             </a:r>
             <a:endParaRPr lang="en-US" sz="1250" dirty="0"/>
           </a:p>
@@ -4948,7 +4948,7 @@
                 <a:ea typeface="Calibri" pitchFamily="34" charset="-122"/>
                 <a:cs typeface="Calibri" pitchFamily="34" charset="-120"/>
               </a:rPr>
-              <a:t>de libellé vérifiée par test</a:t>
+              <a:t>base simulée, sans réentraînement</a:t>
             </a:r>
             <a:endParaRPr lang="en-US" sz="1250" dirty="0"/>
           </a:p>
@@ -4962,8 +4962,8 @@
         </p:nvSpPr>
         <p:spPr>
           <a:xfrm>
-            <a:off x="1097280" y="4754880"/>
-            <a:ext cx="10058400" cy="822960"/>
+            <a:off x="1097280" y="4343400"/>
+            <a:ext cx="10058400" cy="640080"/>
           </a:xfrm>
           <a:prstGeom prst="rect">
             <a:avLst/>
@@ -4979,7 +4979,7 @@
               <a:buNone/>
             </a:pPr>
             <a:r>
-              <a:rPr lang="en-US" sz="1450" dirty="0">
+              <a:rPr lang="en-US" sz="1400" dirty="0">
                 <a:solidFill>
                   <a:srgbClr val="8B99A8"/>
                 </a:solidFill>
@@ -4989,7 +4989,46 @@
               </a:rPr>
               <a:t>Tests d'intégration Streamlit (AppTest), tests E2E du cycle enregistrer → recharger → superviser, invariants d'import du moteur, pipeline ML reproductible en CI.</a:t>
             </a:r>
-            <a:endParaRPr lang="en-US" sz="1450" dirty="0"/>
+            <a:endParaRPr lang="en-US" sz="1400" dirty="0"/>
+          </a:p>
+        </p:txBody>
+      </p:sp>
+      <p:sp>
+        <p:nvSpPr>
+          <p:cNvPr id="14" name="Text 12"/>
+          <p:cNvSpPr/>
+          <p:nvPr/>
+        </p:nvSpPr>
+        <p:spPr>
+          <a:xfrm>
+            <a:off x="1097280" y="5029200"/>
+            <a:ext cx="10058400" cy="731520"/>
+          </a:xfrm>
+          <a:prstGeom prst="rect">
+            <a:avLst/>
+          </a:prstGeom>
+          <a:noFill/>
+          <a:ln/>
+        </p:spPr>
+        <p:txBody>
+          <a:bodyPr wrap="square" lIns="0" tIns="0" rIns="0" bIns="0" rtlCol="0" anchor="ctr"/>
+          <a:lstStyle/>
+          <a:p>
+            <a:pPr algn="ctr" indent="0" marL="0">
+              <a:buNone/>
+            </a:pPr>
+            <a:r>
+              <a:rPr lang="en-US" sz="1300" i="1" dirty="0">
+                <a:solidFill>
+                  <a:srgbClr val="8B99A8"/>
+                </a:solidFill>
+                <a:latin typeface="Calibri" pitchFamily="34" charset="0"/>
+                <a:ea typeface="Calibri" pitchFamily="34" charset="-122"/>
+                <a:cs typeface="Calibri" pitchFamily="34" charset="-120"/>
+              </a:rPr>
+              <a:t>Validation externe : 3 479 fenêtres issues de 15 runs simulés passées dans le même pipeline que le réel — résultat volontairement non optimisé, erreurs majoritairement conservatrices.</a:t>
+            </a:r>
+            <a:endParaRPr lang="en-US" sz="1300" dirty="0"/>
           </a:p>
         </p:txBody>
       </p:sp>

</xml_diff>

<commit_message>
chore(dépôt): politiques RLS auth_tables.sql + livrables soutenance à jour (704 tests, auth)
- database/auth_tables.sql : politiques RLS actives (app_users, login_history)
- guide, PPT, mémoire alignés sur l'authentification et 704 tests
- doc d'audit de préparation ajouté

Co-Authored-By: Claude Opus 4.8 <noreply@anthropic.com>
</commit_message>
<xml_diff>
--- a/reports/soutenance/MBEUMI_Wilfried_SOUTENANCE.pptx
+++ b/reports/soutenance/MBEUMI_Wilfried_SOUTENANCE.pptx
@@ -4472,7 +4472,7 @@
                 <a:ea typeface="Calibri" pitchFamily="34" charset="-122"/>
                 <a:cs typeface="Calibri" pitchFamily="34" charset="-120"/>
               </a:rPr>
-              <a:t>694 tests automatisés en CI · veille scientifique (extrusion, SSB, ML industriel) alimentant l'état de l'art et les choix technologiques.</a:t>
+              <a:t>704 tests automatisés en CI · veille scientifique (extrusion, SSB, ML industriel) alimentant l'état de l'art et les choix technologiques.</a:t>
             </a:r>
             <a:endParaRPr lang="en-US" sz="1250" dirty="0"/>
           </a:p>
@@ -4648,7 +4648,7 @@
                 <a:ea typeface="Cambria" pitchFamily="34" charset="-122"/>
                 <a:cs typeface="Cambria" pitchFamily="34" charset="-120"/>
               </a:rPr>
-              <a:t>694</a:t>
+              <a:t>704</a:t>
             </a:r>
             <a:endParaRPr lang="en-US" sz="4800" dirty="0"/>
           </a:p>

</xml_diff>

<commit_message>
chore(sync): 705 tests (auto-provision local ajouté), livrables réalignés
- 704→705 partout (mémoire, PDR, PPT, guide, check_sync) ; 11 tests auth
- mémoire/guide/PPT rebuild, check_sync vert, deck validé

Co-Authored-By: Claude Opus 4.8 <noreply@anthropic.com>
</commit_message>
<xml_diff>
--- a/reports/soutenance/MBEUMI_Wilfried_SOUTENANCE.pptx
+++ b/reports/soutenance/MBEUMI_Wilfried_SOUTENANCE.pptx
@@ -4472,7 +4472,7 @@
                 <a:ea typeface="Calibri" pitchFamily="34" charset="-122"/>
                 <a:cs typeface="Calibri" pitchFamily="34" charset="-120"/>
               </a:rPr>
-              <a:t>704 tests automatisés en CI · veille scientifique (extrusion, SSB, ML industriel) alimentant l'état de l'art et les choix technologiques.</a:t>
+              <a:t>705 tests automatisés en CI · veille scientifique (extrusion, SSB, ML industriel) alimentant l'état de l'art et les choix technologiques.</a:t>
             </a:r>
             <a:endParaRPr lang="en-US" sz="1250" dirty="0"/>
           </a:p>
@@ -4648,7 +4648,7 @@
                 <a:ea typeface="Cambria" pitchFamily="34" charset="-122"/>
                 <a:cs typeface="Cambria" pitchFamily="34" charset="-120"/>
               </a:rPr>
-              <a:t>704</a:t>
+              <a:t>705</a:t>
             </a:r>
             <a:endParaRPr lang="en-US" sz="4800" dirty="0"/>
           </a:p>

</xml_diff>

<commit_message>
fix(soutenance): PowerPoint et guide alignés sur l'app (7 pages + authentification)
Le PPT ne mentionnait pas l'authentification et affichait encore « 6 pages » ;
le guide idem. Corrigés :
- diapo Application : sous-titre « 7 pages, accès protégé », 7e carte
  « Compte & accès » (PBKDF2 + historique des connexions), grille 4×2
- couche HMI de l'architecture : page Compte ajoutée
- guide : « sept pages Streamlit », « 7 pages · accès protégé »
- contrôle géométrique : aucun texte hors cadre sur les 14 diapos

Co-Authored-By: Claude Opus 4.8 <noreply@anthropic.com>
</commit_message>
<xml_diff>
--- a/reports/soutenance/MBEUMI_Wilfried_SOUTENANCE.pptx
+++ b/reports/soutenance/MBEUMI_Wilfried_SOUTENANCE.pptx
@@ -3076,7 +3076,7 @@
                 <a:ea typeface="Calibri" pitchFamily="34" charset="-122"/>
                 <a:cs typeface="Calibri" pitchFamily="34" charset="-120"/>
               </a:rPr>
-              <a:t>6 pages, bilingue FR/EN, persistance 3 couches (édition → validé → historique)</a:t>
+              <a:t>7 pages, accès protégé, bilingue FR/EN, persistance 3 couches (édition → validé → historique)</a:t>
             </a:r>
             <a:endParaRPr lang="en-US" sz="1300" dirty="0"/>
           </a:p>
@@ -3090,12 +3090,12 @@
         </p:nvSpPr>
         <p:spPr>
           <a:xfrm>
-            <a:off x="548640" y="1828800"/>
-            <a:ext cx="3566160" cy="1965960"/>
+            <a:off x="548640" y="1874520"/>
+            <a:ext cx="2606040" cy="1993392"/>
           </a:xfrm>
           <a:prstGeom prst="roundRect">
             <a:avLst>
-              <a:gd name="adj" fmla="val 3721"/>
+              <a:gd name="adj" fmla="val 3670"/>
             </a:avLst>
           </a:prstGeom>
           <a:solidFill>
@@ -3117,8 +3117,8 @@
         </p:nvSpPr>
         <p:spPr>
           <a:xfrm>
-            <a:off x="822960" y="2029968"/>
-            <a:ext cx="3017520" cy="365760"/>
+            <a:off x="749808" y="2039112"/>
+            <a:ext cx="2240280" cy="384048"/>
           </a:xfrm>
           <a:prstGeom prst="rect">
             <a:avLst/>
@@ -3134,7 +3134,7 @@
               <a:buNone/>
             </a:pPr>
             <a:r>
-              <a:rPr lang="en-US" sz="1550" b="1" dirty="0">
+              <a:rPr lang="en-US" sz="1350" b="1" dirty="0">
                 <a:solidFill>
                   <a:srgbClr val="2DD4BF"/>
                 </a:solidFill>
@@ -3144,7 +3144,7 @@
               </a:rPr>
               <a:t>Supervision</a:t>
             </a:r>
-            <a:endParaRPr lang="en-US" sz="1550" dirty="0"/>
+            <a:endParaRPr lang="en-US" sz="1350" dirty="0"/>
           </a:p>
         </p:txBody>
       </p:sp>
@@ -3156,8 +3156,8 @@
         </p:nvSpPr>
         <p:spPr>
           <a:xfrm>
-            <a:off x="822960" y="2450592"/>
-            <a:ext cx="3063240" cy="1234440"/>
+            <a:off x="749808" y="2459736"/>
+            <a:ext cx="2240280" cy="1298448"/>
           </a:xfrm>
           <a:prstGeom prst="rect">
             <a:avLst/>
@@ -3173,7 +3173,7 @@
               <a:buNone/>
             </a:pPr>
             <a:r>
-              <a:rPr lang="en-US" sz="1250" dirty="0">
+              <a:rPr lang="en-US" sz="1100" dirty="0">
                 <a:solidFill>
                   <a:srgbClr val="EAF2F4"/>
                 </a:solidFill>
@@ -3183,7 +3183,7 @@
               </a:rPr>
               <a:t>score de stabilité ML, probabilité de dérive, alertes et recommandations IA en direct</a:t>
             </a:r>
-            <a:endParaRPr lang="en-US" sz="1250" dirty="0"/>
+            <a:endParaRPr lang="en-US" sz="1100" dirty="0"/>
           </a:p>
         </p:txBody>
       </p:sp>
@@ -3195,12 +3195,12 @@
         </p:nvSpPr>
         <p:spPr>
           <a:xfrm>
-            <a:off x="4370832" y="1828800"/>
-            <a:ext cx="3566160" cy="1965960"/>
+            <a:off x="3364992" y="1874520"/>
+            <a:ext cx="2606040" cy="1993392"/>
           </a:xfrm>
           <a:prstGeom prst="roundRect">
             <a:avLst>
-              <a:gd name="adj" fmla="val 3721"/>
+              <a:gd name="adj" fmla="val 3670"/>
             </a:avLst>
           </a:prstGeom>
           <a:solidFill>
@@ -3222,8 +3222,8 @@
         </p:nvSpPr>
         <p:spPr>
           <a:xfrm>
-            <a:off x="4645152" y="2029968"/>
-            <a:ext cx="3017520" cy="365760"/>
+            <a:off x="3566160" y="2039112"/>
+            <a:ext cx="2240280" cy="384048"/>
           </a:xfrm>
           <a:prstGeom prst="rect">
             <a:avLst/>
@@ -3239,7 +3239,7 @@
               <a:buNone/>
             </a:pPr>
             <a:r>
-              <a:rPr lang="en-US" sz="1550" b="1" dirty="0">
+              <a:rPr lang="en-US" sz="1350" b="1" dirty="0">
                 <a:solidFill>
                   <a:srgbClr val="2DD4BF"/>
                 </a:solidFill>
@@ -3249,7 +3249,7 @@
               </a:rPr>
               <a:t>Configuration vis</a:t>
             </a:r>
-            <a:endParaRPr lang="en-US" sz="1550" dirty="0"/>
+            <a:endParaRPr lang="en-US" sz="1350" dirty="0"/>
           </a:p>
         </p:txBody>
       </p:sp>
@@ -3261,8 +3261,8 @@
         </p:nvSpPr>
         <p:spPr>
           <a:xfrm>
-            <a:off x="4645152" y="2450592"/>
-            <a:ext cx="3063240" cy="1234440"/>
+            <a:off x="3566160" y="2459736"/>
+            <a:ext cx="2240280" cy="1298448"/>
           </a:xfrm>
           <a:prstGeom prst="rect">
             <a:avLst/>
@@ -3278,7 +3278,7 @@
               <a:buNone/>
             </a:pPr>
             <a:r>
-              <a:rPr lang="en-US" sz="1250" dirty="0">
+              <a:rPr lang="en-US" sz="1100" dirty="0">
                 <a:solidFill>
                   <a:srgbClr val="EAF2F4"/>
                 </a:solidFill>
@@ -3288,7 +3288,7 @@
               </a:rPr>
               <a:t>construction du profil 81 positions, KPIs procédé recalculés à chaque geste</a:t>
             </a:r>
-            <a:endParaRPr lang="en-US" sz="1250" dirty="0"/>
+            <a:endParaRPr lang="en-US" sz="1100" dirty="0"/>
           </a:p>
         </p:txBody>
       </p:sp>
@@ -3300,12 +3300,12 @@
         </p:nvSpPr>
         <p:spPr>
           <a:xfrm>
-            <a:off x="8193024" y="1828800"/>
-            <a:ext cx="3566160" cy="1965960"/>
+            <a:off x="6181344" y="1874520"/>
+            <a:ext cx="2606040" cy="1993392"/>
           </a:xfrm>
           <a:prstGeom prst="roundRect">
             <a:avLst>
-              <a:gd name="adj" fmla="val 3721"/>
+              <a:gd name="adj" fmla="val 3670"/>
             </a:avLst>
           </a:prstGeom>
           <a:solidFill>
@@ -3327,8 +3327,8 @@
         </p:nvSpPr>
         <p:spPr>
           <a:xfrm>
-            <a:off x="8467344" y="2029968"/>
-            <a:ext cx="3017520" cy="365760"/>
+            <a:off x="6382512" y="2039112"/>
+            <a:ext cx="2240280" cy="384048"/>
           </a:xfrm>
           <a:prstGeom prst="rect">
             <a:avLst/>
@@ -3344,7 +3344,7 @@
               <a:buNone/>
             </a:pPr>
             <a:r>
-              <a:rPr lang="en-US" sz="1550" b="1" dirty="0">
+              <a:rPr lang="en-US" sz="1350" b="1" dirty="0">
                 <a:solidFill>
                   <a:srgbClr val="2DD4BF"/>
                 </a:solidFill>
@@ -3354,7 +3354,7 @@
               </a:rPr>
               <a:t>Paramètres IA &amp; feeders</a:t>
             </a:r>
-            <a:endParaRPr lang="en-US" sz="1550" dirty="0"/>
+            <a:endParaRPr lang="en-US" sz="1350" dirty="0"/>
           </a:p>
         </p:txBody>
       </p:sp>
@@ -3366,8 +3366,8 @@
         </p:nvSpPr>
         <p:spPr>
           <a:xfrm>
-            <a:off x="8467344" y="2450592"/>
-            <a:ext cx="3063240" cy="1234440"/>
+            <a:off x="6382512" y="2459736"/>
+            <a:ext cx="2240280" cy="1298448"/>
           </a:xfrm>
           <a:prstGeom prst="rect">
             <a:avLst/>
@@ -3383,7 +3383,7 @@
               <a:buNone/>
             </a:pPr>
             <a:r>
-              <a:rPr lang="en-US" sz="1250" dirty="0">
+              <a:rPr lang="en-US" sz="1100" dirty="0">
                 <a:solidFill>
                   <a:srgbClr val="EAF2F4"/>
                 </a:solidFill>
@@ -3393,7 +3393,7 @@
               </a:rPr>
               <a:t>seuils, matières, calibration doseurs — rien n'impacte la supervision avant validation</a:t>
             </a:r>
-            <a:endParaRPr lang="en-US" sz="1250" dirty="0"/>
+            <a:endParaRPr lang="en-US" sz="1100" dirty="0"/>
           </a:p>
         </p:txBody>
       </p:sp>
@@ -3405,12 +3405,12 @@
         </p:nvSpPr>
         <p:spPr>
           <a:xfrm>
-            <a:off x="548640" y="4023360"/>
-            <a:ext cx="3566160" cy="1965960"/>
+            <a:off x="8997696" y="1874520"/>
+            <a:ext cx="2606040" cy="1993392"/>
           </a:xfrm>
           <a:prstGeom prst="roundRect">
             <a:avLst>
-              <a:gd name="adj" fmla="val 3721"/>
+              <a:gd name="adj" fmla="val 3670"/>
             </a:avLst>
           </a:prstGeom>
           <a:solidFill>
@@ -3432,8 +3432,8 @@
         </p:nvSpPr>
         <p:spPr>
           <a:xfrm>
-            <a:off x="822960" y="4224528"/>
-            <a:ext cx="3017520" cy="365760"/>
+            <a:off x="9198864" y="2039112"/>
+            <a:ext cx="2240280" cy="384048"/>
           </a:xfrm>
           <a:prstGeom prst="rect">
             <a:avLst/>
@@ -3449,7 +3449,7 @@
               <a:buNone/>
             </a:pPr>
             <a:r>
-              <a:rPr lang="en-US" sz="1550" b="1" dirty="0">
+              <a:rPr lang="en-US" sz="1350" b="1" dirty="0">
                 <a:solidFill>
                   <a:srgbClr val="2DD4BF"/>
                 </a:solidFill>
@@ -3459,7 +3459,7 @@
               </a:rPr>
               <a:t>Analyse de run</a:t>
             </a:r>
-            <a:endParaRPr lang="en-US" sz="1550" dirty="0"/>
+            <a:endParaRPr lang="en-US" sz="1350" dirty="0"/>
           </a:p>
         </p:txBody>
       </p:sp>
@@ -3471,8 +3471,8 @@
         </p:nvSpPr>
         <p:spPr>
           <a:xfrm>
-            <a:off x="822960" y="4645152"/>
-            <a:ext cx="3063240" cy="1234440"/>
+            <a:off x="9198864" y="2459736"/>
+            <a:ext cx="2240280" cy="1298448"/>
           </a:xfrm>
           <a:prstGeom prst="rect">
             <a:avLst/>
@@ -3488,7 +3488,7 @@
               <a:buNone/>
             </a:pPr>
             <a:r>
-              <a:rPr lang="en-US" sz="1250" dirty="0">
+              <a:rPr lang="en-US" sz="1100" dirty="0">
                 <a:solidFill>
                   <a:srgbClr val="EAF2F4"/>
                 </a:solidFill>
@@ -3498,7 +3498,7 @@
               </a:rPr>
               <a:t>relecture temporelle d'une production : fenêtres, score, profil thermique</a:t>
             </a:r>
-            <a:endParaRPr lang="en-US" sz="1250" dirty="0"/>
+            <a:endParaRPr lang="en-US" sz="1100" dirty="0"/>
           </a:p>
         </p:txBody>
       </p:sp>
@@ -3510,12 +3510,12 @@
         </p:nvSpPr>
         <p:spPr>
           <a:xfrm>
-            <a:off x="4370832" y="4023360"/>
-            <a:ext cx="3566160" cy="1965960"/>
+            <a:off x="548640" y="4087368"/>
+            <a:ext cx="2606040" cy="1993392"/>
           </a:xfrm>
           <a:prstGeom prst="roundRect">
             <a:avLst>
-              <a:gd name="adj" fmla="val 3721"/>
+              <a:gd name="adj" fmla="val 3670"/>
             </a:avLst>
           </a:prstGeom>
           <a:solidFill>
@@ -3537,8 +3537,8 @@
         </p:nvSpPr>
         <p:spPr>
           <a:xfrm>
-            <a:off x="4645152" y="4224528"/>
-            <a:ext cx="3017520" cy="365760"/>
+            <a:off x="749808" y="4251960"/>
+            <a:ext cx="2240280" cy="384048"/>
           </a:xfrm>
           <a:prstGeom prst="rect">
             <a:avLst/>
@@ -3554,7 +3554,7 @@
               <a:buNone/>
             </a:pPr>
             <a:r>
-              <a:rPr lang="en-US" sz="1550" b="1" dirty="0">
+              <a:rPr lang="en-US" sz="1350" b="1" dirty="0">
                 <a:solidFill>
                   <a:srgbClr val="2DD4BF"/>
                 </a:solidFill>
@@ -3564,7 +3564,7 @@
               </a:rPr>
               <a:t>Historique</a:t>
             </a:r>
-            <a:endParaRPr lang="en-US" sz="1550" dirty="0"/>
+            <a:endParaRPr lang="en-US" sz="1350" dirty="0"/>
           </a:p>
         </p:txBody>
       </p:sp>
@@ -3576,8 +3576,8 @@
         </p:nvSpPr>
         <p:spPr>
           <a:xfrm>
-            <a:off x="4645152" y="4645152"/>
-            <a:ext cx="3063240" cy="1234440"/>
+            <a:off x="749808" y="4672584"/>
+            <a:ext cx="2240280" cy="1298448"/>
           </a:xfrm>
           <a:prstGeom prst="rect">
             <a:avLst/>
@@ -3593,7 +3593,7 @@
               <a:buNone/>
             </a:pPr>
             <a:r>
-              <a:rPr lang="en-US" sz="1250" dirty="0">
+              <a:rPr lang="en-US" sz="1100" dirty="0">
                 <a:solidFill>
                   <a:srgbClr val="EAF2F4"/>
                 </a:solidFill>
@@ -3603,7 +3603,7 @@
               </a:rPr>
               <a:t>chaque configuration validée est figée avec ses KPIs — traçabilité R&amp;D</a:t>
             </a:r>
-            <a:endParaRPr lang="en-US" sz="1250" dirty="0"/>
+            <a:endParaRPr lang="en-US" sz="1100" dirty="0"/>
           </a:p>
         </p:txBody>
       </p:sp>
@@ -3615,12 +3615,12 @@
         </p:nvSpPr>
         <p:spPr>
           <a:xfrm>
-            <a:off x="8193024" y="4023360"/>
-            <a:ext cx="3566160" cy="1965960"/>
+            <a:off x="3364992" y="4087368"/>
+            <a:ext cx="2606040" cy="1993392"/>
           </a:xfrm>
           <a:prstGeom prst="roundRect">
             <a:avLst>
-              <a:gd name="adj" fmla="val 3721"/>
+              <a:gd name="adj" fmla="val 3670"/>
             </a:avLst>
           </a:prstGeom>
           <a:solidFill>
@@ -3642,8 +3642,8 @@
         </p:nvSpPr>
         <p:spPr>
           <a:xfrm>
-            <a:off x="8467344" y="4224528"/>
-            <a:ext cx="3017520" cy="365760"/>
+            <a:off x="3566160" y="4251960"/>
+            <a:ext cx="2240280" cy="384048"/>
           </a:xfrm>
           <a:prstGeom prst="rect">
             <a:avLst/>
@@ -3659,7 +3659,7 @@
               <a:buNone/>
             </a:pPr>
             <a:r>
-              <a:rPr lang="en-US" sz="1550" b="1" dirty="0">
+              <a:rPr lang="en-US" sz="1350" b="1" dirty="0">
                 <a:solidFill>
                   <a:srgbClr val="2DD4BF"/>
                 </a:solidFill>
@@ -3669,7 +3669,7 @@
               </a:rPr>
               <a:t>Moteur procédé</a:t>
             </a:r>
-            <a:endParaRPr lang="en-US" sz="1550" dirty="0"/>
+            <a:endParaRPr lang="en-US" sz="1350" dirty="0"/>
           </a:p>
         </p:txBody>
       </p:sp>
@@ -3681,8 +3681,8 @@
         </p:nvSpPr>
         <p:spPr>
           <a:xfrm>
-            <a:off x="8467344" y="4645152"/>
-            <a:ext cx="3063240" cy="1234440"/>
+            <a:off x="3566160" y="4672584"/>
+            <a:ext cx="2240280" cy="1298448"/>
           </a:xfrm>
           <a:prstGeom prst="rect">
             <a:avLst/>
@@ -3698,7 +3698,7 @@
               <a:buNone/>
             </a:pPr>
             <a:r>
-              <a:rPr lang="en-US" sz="1250" dirty="0">
+              <a:rPr lang="en-US" sz="1100" dirty="0">
                 <a:solidFill>
                   <a:srgbClr val="EAF2F4"/>
                 </a:solidFill>
@@ -3708,7 +3708,112 @@
               </a:rPr>
               <a:t>vue transparente de la physique : chaque nombre affiché est justifiable</a:t>
             </a:r>
-            <a:endParaRPr lang="en-US" sz="1250" dirty="0"/>
+            <a:endParaRPr lang="en-US" sz="1100" dirty="0"/>
+          </a:p>
+        </p:txBody>
+      </p:sp>
+      <p:sp>
+        <p:nvSpPr>
+          <p:cNvPr id="22" name="Shape 20"/>
+          <p:cNvSpPr/>
+          <p:nvPr/>
+        </p:nvSpPr>
+        <p:spPr>
+          <a:xfrm>
+            <a:off x="6181344" y="4087368"/>
+            <a:ext cx="2606040" cy="1993392"/>
+          </a:xfrm>
+          <a:prstGeom prst="roundRect">
+            <a:avLst>
+              <a:gd name="adj" fmla="val 3670"/>
+            </a:avLst>
+          </a:prstGeom>
+          <a:solidFill>
+            <a:srgbClr val="1C232E"/>
+          </a:solidFill>
+          <a:ln w="9525">
+            <a:solidFill>
+              <a:srgbClr val="2A3442"/>
+            </a:solidFill>
+            <a:prstDash val="solid"/>
+          </a:ln>
+        </p:spPr>
+      </p:sp>
+      <p:sp>
+        <p:nvSpPr>
+          <p:cNvPr id="23" name="Text 21"/>
+          <p:cNvSpPr/>
+          <p:nvPr/>
+        </p:nvSpPr>
+        <p:spPr>
+          <a:xfrm>
+            <a:off x="6382512" y="4251960"/>
+            <a:ext cx="2240280" cy="384048"/>
+          </a:xfrm>
+          <a:prstGeom prst="rect">
+            <a:avLst/>
+          </a:prstGeom>
+          <a:noFill/>
+          <a:ln/>
+        </p:spPr>
+        <p:txBody>
+          <a:bodyPr wrap="square" lIns="0" tIns="0" rIns="0" bIns="0" rtlCol="0" anchor="ctr"/>
+          <a:lstStyle/>
+          <a:p>
+            <a:pPr indent="0" marL="0">
+              <a:buNone/>
+            </a:pPr>
+            <a:r>
+              <a:rPr lang="en-US" sz="1350" b="1" dirty="0">
+                <a:solidFill>
+                  <a:srgbClr val="2DD4BF"/>
+                </a:solidFill>
+                <a:latin typeface="Calibri" pitchFamily="34" charset="0"/>
+                <a:ea typeface="Calibri" pitchFamily="34" charset="-122"/>
+                <a:cs typeface="Calibri" pitchFamily="34" charset="-120"/>
+              </a:rPr>
+              <a:t>Compte &amp; accès</a:t>
+            </a:r>
+            <a:endParaRPr lang="en-US" sz="1350" dirty="0"/>
+          </a:p>
+        </p:txBody>
+      </p:sp>
+      <p:sp>
+        <p:nvSpPr>
+          <p:cNvPr id="24" name="Text 22"/>
+          <p:cNvSpPr/>
+          <p:nvPr/>
+        </p:nvSpPr>
+        <p:spPr>
+          <a:xfrm>
+            <a:off x="6382512" y="4672584"/>
+            <a:ext cx="2240280" cy="1298448"/>
+          </a:xfrm>
+          <a:prstGeom prst="rect">
+            <a:avLst/>
+          </a:prstGeom>
+          <a:noFill/>
+          <a:ln/>
+        </p:spPr>
+        <p:txBody>
+          <a:bodyPr wrap="square" lIns="0" tIns="0" rIns="0" bIns="0" rtlCol="0" anchor="ctr"/>
+          <a:lstStyle/>
+          <a:p>
+            <a:pPr indent="0" marL="0">
+              <a:buNone/>
+            </a:pPr>
+            <a:r>
+              <a:rPr lang="en-US" sz="1100" dirty="0">
+                <a:solidFill>
+                  <a:srgbClr val="EAF2F4"/>
+                </a:solidFill>
+                <a:latin typeface="Calibri" pitchFamily="34" charset="0"/>
+                <a:ea typeface="Calibri" pitchFamily="34" charset="-122"/>
+                <a:cs typeface="Calibri" pitchFamily="34" charset="-120"/>
+              </a:rPr>
+              <a:t>connexion requise (mot de passe haché PBKDF2) et historique des connexions lu en base</a:t>
+            </a:r>
+            <a:endParaRPr lang="en-US" sz="1100" dirty="0"/>
           </a:p>
         </p:txBody>
       </p:sp>
@@ -6778,7 +6883,7 @@
                 <a:ea typeface="Calibri" pitchFamily="34" charset="-122"/>
                 <a:cs typeface="Calibri" pitchFamily="34" charset="-120"/>
               </a:rPr>
-              <a:t>Supervision · Configuration vis · Paramètres IA · Analyse de run · Historique · Moteur procédé</a:t>
+              <a:t>Supervision · Configuration vis · Paramètres IA · Analyse de run · Historique · Moteur procédé · Compte</a:t>
             </a:r>
             <a:endParaRPr lang="en-US" sz="1250" dirty="0"/>
           </a:p>

</xml_diff>

<commit_message>
fix(soutenance): PPT et guide alignés sur la méthode Kanban du mémoire
Le mémoire nomme désormais explicitement Kanban comme méthode de gestion de
projet (ajout précédent). Le PPT (diapo 12) et le guide (script diapo 12 +
Q&A) disaient encore "itérations agile" sans nommer la méthode — un jury
posant la question "quelle méthode ?" n'aurait pas trouvé le mot sur l'écran.
PREZ.pdf régénéré en conséquence.

Co-Authored-By: Claude Sonnet 4.5 <noreply@anthropic.com>
</commit_message>
<xml_diff>
--- a/reports/soutenance/MBEUMI_Wilfried_SOUTENANCE.pptx
+++ b/reports/soutenance/MBEUMI_Wilfried_SOUTENANCE.pptx
@@ -4046,7 +4046,7 @@
                 <a:ea typeface="Calibri" pitchFamily="34" charset="-122"/>
                 <a:cs typeface="Calibri" pitchFamily="34" charset="-120"/>
               </a:rPr>
-              <a:t>Méthode</a:t>
+              <a:t>Méthode : Kanban</a:t>
             </a:r>
             <a:endParaRPr lang="en-US" sz="1650" dirty="0"/>
           </a:p>
@@ -4085,7 +4085,7 @@
                 <a:ea typeface="Calibri" pitchFamily="34" charset="-122"/>
                 <a:cs typeface="Calibri" pitchFamily="34" charset="-120"/>
               </a:rPr>
-              <a:t>Itérations courtes type agile : proposition → validation encadrant → développement → tests → démo. Chaque brique validée avant la suivante.</a:t>
+              <a:t>Flux tiré à encours limité (WIP=1) : proposition → validation encadrant → développement → tests → démo. Aucune brique entamée avant la validation de la précédente.</a:t>
             </a:r>
             <a:endParaRPr lang="en-US" sz="1250" dirty="0"/>
           </a:p>

</xml_diff>